<commit_message>
Add Ivan Romanov as 5th team member
- Slide 1 team block rebuilt as single column of 5 rows
- Report cover line updated to include all 5 members
- group_xxx.zip repackaged
</commit_message>
<xml_diff>
--- a/deliverables/group_xxx_presentation.pptx
+++ b/deliverables/group_xxx_presentation.pptx
@@ -26377,16 +26377,191 @@
           </a:fontRef>
         </p:style>
       </p:cxnSp>
-      <p:sp>
-        <p:nvSpPr>
-          <p:cNvPr id="531" name="TextBox 530"/>
+      <p:cxnSp>
+        <p:nvCxnSpPr>
+          <p:cNvPr id="534" name="Connector 533"/>
+          <p:cNvCxnSpPr/>
+          <p:nvPr/>
+        </p:nvCxnSpPr>
+        <p:spPr>
+          <a:xfrm>
+            <a:off x="5349240" y="5532120.0"/>
+            <a:ext cx="6583680" cy="0.0"/>
+          </a:xfrm>
+          <a:prstGeom prst="line">
+            <a:avLst/>
+          </a:prstGeom>
+          <a:ln w="5080">
+            <a:solidFill>
+              <a:srgbClr val="ECE6D6"/>
+            </a:solidFill>
+          </a:ln>
+        </p:spPr>
+        <p:style>
+          <a:lnRef idx="2">
+            <a:schemeClr val="accent1"/>
+          </a:lnRef>
+          <a:fillRef idx="0">
+            <a:schemeClr val="accent1"/>
+          </a:fillRef>
+          <a:effectRef idx="1">
+            <a:schemeClr val="accent1"/>
+          </a:effectRef>
+          <a:fontRef idx="minor">
+            <a:schemeClr val="tx1"/>
+          </a:fontRef>
+        </p:style>
+      </p:cxnSp>
+      <p:cxnSp>
+        <p:nvCxnSpPr>
+          <p:cNvPr id="538" name="Connector 537"/>
+          <p:cNvCxnSpPr/>
+          <p:nvPr/>
+        </p:nvCxnSpPr>
+        <p:spPr>
+          <a:xfrm>
+            <a:off x="5349240" y="5879592.0"/>
+            <a:ext cx="6583680" cy="0.0"/>
+          </a:xfrm>
+          <a:prstGeom prst="line">
+            <a:avLst/>
+          </a:prstGeom>
+          <a:ln w="5080">
+            <a:solidFill>
+              <a:srgbClr val="ECE6D6"/>
+            </a:solidFill>
+          </a:ln>
+        </p:spPr>
+        <p:style>
+          <a:lnRef idx="2">
+            <a:schemeClr val="accent1"/>
+          </a:lnRef>
+          <a:fillRef idx="0">
+            <a:schemeClr val="accent1"/>
+          </a:fillRef>
+          <a:effectRef idx="1">
+            <a:schemeClr val="accent1"/>
+          </a:effectRef>
+          <a:fontRef idx="minor">
+            <a:schemeClr val="tx1"/>
+          </a:fontRef>
+        </p:style>
+      </p:cxnSp>
+      <p:cxnSp>
+        <p:nvCxnSpPr>
+          <p:cNvPr id="542" name="Connector 541"/>
+          <p:cNvCxnSpPr/>
+          <p:nvPr/>
+        </p:nvCxnSpPr>
+        <p:spPr>
+          <a:xfrm>
+            <a:off x="5349240" y="6227064.0"/>
+            <a:ext cx="6583680" cy="0.0"/>
+          </a:xfrm>
+          <a:prstGeom prst="line">
+            <a:avLst/>
+          </a:prstGeom>
+          <a:ln w="5080">
+            <a:solidFill>
+              <a:srgbClr val="ECE6D6"/>
+            </a:solidFill>
+          </a:ln>
+        </p:spPr>
+        <p:style>
+          <a:lnRef idx="2">
+            <a:schemeClr val="accent1"/>
+          </a:lnRef>
+          <a:fillRef idx="0">
+            <a:schemeClr val="accent1"/>
+          </a:fillRef>
+          <a:effectRef idx="1">
+            <a:schemeClr val="accent1"/>
+          </a:effectRef>
+          <a:fontRef idx="minor">
+            <a:schemeClr val="tx1"/>
+          </a:fontRef>
+        </p:style>
+      </p:cxnSp>
+      <p:cxnSp>
+        <p:nvCxnSpPr>
+          <p:cNvPr id="546" name="Connector 545"/>
+          <p:cNvCxnSpPr/>
+          <p:nvPr/>
+        </p:nvCxnSpPr>
+        <p:spPr>
+          <a:xfrm>
+            <a:off x="5349240" y="6574536.0"/>
+            <a:ext cx="6583680" cy="0.0"/>
+          </a:xfrm>
+          <a:prstGeom prst="line">
+            <a:avLst/>
+          </a:prstGeom>
+          <a:ln w="5080">
+            <a:solidFill>
+              <a:srgbClr val="ECE6D6"/>
+            </a:solidFill>
+          </a:ln>
+        </p:spPr>
+        <p:style>
+          <a:lnRef idx="2">
+            <a:schemeClr val="accent1"/>
+          </a:lnRef>
+          <a:fillRef idx="0">
+            <a:schemeClr val="accent1"/>
+          </a:fillRef>
+          <a:effectRef idx="1">
+            <a:schemeClr val="accent1"/>
+          </a:effectRef>
+          <a:fontRef idx="minor">
+            <a:schemeClr val="tx1"/>
+          </a:fontRef>
+        </p:style>
+      </p:cxnSp>
+      <p:cxnSp>
+        <p:nvCxnSpPr>
+          <p:cNvPr id="547" name="Connector 546"/>
+          <p:cNvCxnSpPr/>
+          <p:nvPr/>
+        </p:nvCxnSpPr>
+        <p:spPr>
+          <a:xfrm>
+            <a:off x="5349240" y="4736592"/>
+            <a:ext cx="6583680" cy="0"/>
+          </a:xfrm>
+          <a:prstGeom prst="line">
+            <a:avLst/>
+          </a:prstGeom>
+          <a:ln w="6350">
+            <a:solidFill>
+              <a:srgbClr val="D8D3C6"/>
+            </a:solidFill>
+          </a:ln>
+        </p:spPr>
+        <p:style>
+          <a:lnRef idx="2">
+            <a:schemeClr val="accent1"/>
+          </a:lnRef>
+          <a:fillRef idx="0">
+            <a:schemeClr val="accent1"/>
+          </a:fillRef>
+          <a:effectRef idx="1">
+            <a:schemeClr val="accent1"/>
+          </a:effectRef>
+          <a:fontRef idx="minor">
+            <a:schemeClr val="tx1"/>
+          </a:fontRef>
+        </p:style>
+      </p:cxnSp>
+      <p:sp>
+        <p:nvSpPr>
+          <p:cNvPr id="548" name="TextBox 547"/>
           <p:cNvSpPr txBox="1"/>
           <p:nvPr/>
         </p:nvSpPr>
         <p:spPr>
           <a:xfrm>
-            <a:off x="5349240" y="4754880"/>
-            <a:ext cx="3657600" cy="274320"/>
+            <a:off x="5349240" y="4846320"/>
+            <a:ext cx="6400800" cy="274320"/>
           </a:xfrm>
           <a:prstGeom prst="rect">
             <a:avLst/>
@@ -26394,16 +26569,12 @@
           <a:noFill/>
         </p:spPr>
         <p:txBody>
-          <a:bodyPr wrap="square" lIns="0" rIns="0" tIns="0" bIns="0" anchor="t">
+          <a:bodyPr wrap="none" lIns="0" rIns="0" tIns="0" bIns="0" anchor="t">
             <a:spAutoFit/>
           </a:bodyPr>
           <a:lstStyle/>
           <a:p>
-            <a:pPr algn="l">
-              <a:lnSpc>
-                <a:spcPct val="120000"/>
-              </a:lnSpc>
-            </a:pPr>
+            <a:pPr algn="l"/>
             <a:r>
               <a:rPr sz="900" b="1" i="0" spc="400">
                 <a:solidFill>
@@ -26418,14 +26589,14 @@
       </p:sp>
       <p:sp>
         <p:nvSpPr>
-          <p:cNvPr id="532" name="Rectangle 531"/>
-          <p:cNvSpPr/>
-          <p:nvPr/>
-        </p:nvSpPr>
-        <p:spPr>
-          <a:xfrm>
-            <a:off x="5349240" y="5212080"/>
-            <a:ext cx="54864" cy="502920"/>
+          <p:cNvPr id="549" name="Rectangle 548"/>
+          <p:cNvSpPr/>
+          <p:nvPr/>
+        </p:nvSpPr>
+        <p:spPr>
+          <a:xfrm>
+            <a:off x="5349240" y="5102352"/>
+            <a:ext cx="54864" cy="274320"/>
           </a:xfrm>
           <a:prstGeom prst="rect">
             <a:avLst/>
@@ -26460,16 +26631,51 @@
           </a:p>
         </p:txBody>
       </p:sp>
-      <p:sp>
-        <p:nvSpPr>
-          <p:cNvPr id="533" name="TextBox 532"/>
+      <p:cxnSp>
+        <p:nvCxnSpPr>
+          <p:cNvPr id="550" name="Connector 549"/>
+          <p:cNvCxnSpPr/>
+          <p:nvPr/>
+        </p:nvCxnSpPr>
+        <p:spPr>
+          <a:xfrm>
+            <a:off x="5349240" y="5394960.0"/>
+            <a:ext cx="6583680" cy="0.0"/>
+          </a:xfrm>
+          <a:prstGeom prst="line">
+            <a:avLst/>
+          </a:prstGeom>
+          <a:ln w="5080">
+            <a:solidFill>
+              <a:srgbClr val="ECE6D6"/>
+            </a:solidFill>
+          </a:ln>
+        </p:spPr>
+        <p:style>
+          <a:lnRef idx="2">
+            <a:schemeClr val="accent1"/>
+          </a:lnRef>
+          <a:fillRef idx="0">
+            <a:schemeClr val="accent1"/>
+          </a:fillRef>
+          <a:effectRef idx="1">
+            <a:schemeClr val="accent1"/>
+          </a:effectRef>
+          <a:fontRef idx="minor">
+            <a:schemeClr val="tx1"/>
+          </a:fontRef>
+        </p:style>
+      </p:cxnSp>
+      <p:sp>
+        <p:nvSpPr>
+          <p:cNvPr id="551" name="TextBox 550"/>
           <p:cNvSpPr txBox="1"/>
           <p:nvPr/>
         </p:nvSpPr>
         <p:spPr>
           <a:xfrm>
-            <a:off x="5513832" y="5248656"/>
-            <a:ext cx="3017520" cy="274320"/>
+            <a:off x="5532120" y="5102352"/>
+            <a:ext cx="4389120" cy="274320"/>
           </a:xfrm>
           <a:prstGeom prst="rect">
             <a:avLst/>
@@ -26477,18 +26683,18 @@
           <a:noFill/>
         </p:spPr>
         <p:txBody>
-          <a:bodyPr wrap="square" lIns="0" rIns="0" tIns="0" bIns="0" anchor="t">
+          <a:bodyPr wrap="none" lIns="0" rIns="0" tIns="0" bIns="0" anchor="ctr">
             <a:spAutoFit/>
           </a:bodyPr>
           <a:lstStyle/>
           <a:p>
             <a:pPr algn="l"/>
             <a:r>
-              <a:rPr sz="1100">
+              <a:rPr sz="1150" b="1" i="0">
                 <a:solidFill>
-                  <a:srgbClr val="FFFFFF"/>
+                  <a:srgbClr val="101828"/>
                 </a:solidFill>
-                <a:latin typeface="Aptos"/>
+                <a:latin typeface="Helvetica Neue"/>
               </a:rPr>
               <a:t>Daniyal Ahmad</a:t>
             </a:r>
@@ -26497,14 +26703,14 @@
       </p:sp>
       <p:sp>
         <p:nvSpPr>
-          <p:cNvPr id="534" name="TextBox 533"/>
+          <p:cNvPr id="552" name="TextBox 551"/>
           <p:cNvSpPr txBox="1"/>
           <p:nvPr/>
         </p:nvSpPr>
         <p:spPr>
           <a:xfrm>
-            <a:off x="5513832" y="5468112"/>
-            <a:ext cx="3017520" cy="228600"/>
+            <a:off x="9829800" y="5102352"/>
+            <a:ext cx="2057400" cy="274320"/>
           </a:xfrm>
           <a:prstGeom prst="rect">
             <a:avLst/>
@@ -26512,20 +26718,16 @@
           <a:noFill/>
         </p:spPr>
         <p:txBody>
-          <a:bodyPr wrap="square" lIns="0" rIns="0" tIns="0" bIns="0" anchor="t">
+          <a:bodyPr wrap="none" lIns="0" rIns="0" tIns="0" bIns="0" anchor="ctr">
             <a:spAutoFit/>
           </a:bodyPr>
           <a:lstStyle/>
           <a:p>
-            <a:pPr algn="l">
-              <a:lnSpc>
-                <a:spcPct val="120000"/>
-              </a:lnSpc>
-            </a:pPr>
+            <a:pPr algn="r"/>
             <a:r>
-              <a:rPr sz="950" b="0" i="0">
+              <a:rPr sz="1050" b="0" i="0">
                 <a:solidFill>
-                  <a:srgbClr val="5F6A7A"/>
+                  <a:srgbClr val="00684A"/>
                 </a:solidFill>
                 <a:latin typeface="Menlo"/>
               </a:rPr>
@@ -26536,14 +26738,14 @@
       </p:sp>
       <p:sp>
         <p:nvSpPr>
-          <p:cNvPr id="535" name="Rectangle 534"/>
-          <p:cNvSpPr/>
-          <p:nvPr/>
-        </p:nvSpPr>
-        <p:spPr>
-          <a:xfrm>
-            <a:off x="8732520" y="5212080"/>
-            <a:ext cx="54864" cy="502920"/>
+          <p:cNvPr id="553" name="Rectangle 552"/>
+          <p:cNvSpPr/>
+          <p:nvPr/>
+        </p:nvSpPr>
+        <p:spPr>
+          <a:xfrm>
+            <a:off x="5349240" y="5413248"/>
+            <a:ext cx="54864" cy="274320"/>
           </a:xfrm>
           <a:prstGeom prst="rect">
             <a:avLst/>
@@ -26578,16 +26780,51 @@
           </a:p>
         </p:txBody>
       </p:sp>
-      <p:sp>
-        <p:nvSpPr>
-          <p:cNvPr id="536" name="TextBox 535"/>
+      <p:cxnSp>
+        <p:nvCxnSpPr>
+          <p:cNvPr id="554" name="Connector 553"/>
+          <p:cNvCxnSpPr/>
+          <p:nvPr/>
+        </p:nvCxnSpPr>
+        <p:spPr>
+          <a:xfrm>
+            <a:off x="5349240" y="5705856.0"/>
+            <a:ext cx="6583680" cy="0.0"/>
+          </a:xfrm>
+          <a:prstGeom prst="line">
+            <a:avLst/>
+          </a:prstGeom>
+          <a:ln w="5080">
+            <a:solidFill>
+              <a:srgbClr val="ECE6D6"/>
+            </a:solidFill>
+          </a:ln>
+        </p:spPr>
+        <p:style>
+          <a:lnRef idx="2">
+            <a:schemeClr val="accent1"/>
+          </a:lnRef>
+          <a:fillRef idx="0">
+            <a:schemeClr val="accent1"/>
+          </a:fillRef>
+          <a:effectRef idx="1">
+            <a:schemeClr val="accent1"/>
+          </a:effectRef>
+          <a:fontRef idx="minor">
+            <a:schemeClr val="tx1"/>
+          </a:fontRef>
+        </p:style>
+      </p:cxnSp>
+      <p:sp>
+        <p:nvSpPr>
+          <p:cNvPr id="555" name="TextBox 554"/>
           <p:cNvSpPr txBox="1"/>
           <p:nvPr/>
         </p:nvSpPr>
         <p:spPr>
           <a:xfrm>
-            <a:off x="8897112" y="5248656"/>
-            <a:ext cx="3017520" cy="274320"/>
+            <a:off x="5532120" y="5413248"/>
+            <a:ext cx="4389120" cy="274320"/>
           </a:xfrm>
           <a:prstGeom prst="rect">
             <a:avLst/>
@@ -26595,18 +26832,14 @@
           <a:noFill/>
         </p:spPr>
         <p:txBody>
-          <a:bodyPr wrap="square" lIns="0" rIns="0" tIns="0" bIns="0" anchor="t">
+          <a:bodyPr wrap="none" lIns="0" rIns="0" tIns="0" bIns="0" anchor="ctr">
             <a:spAutoFit/>
           </a:bodyPr>
           <a:lstStyle/>
           <a:p>
-            <a:pPr algn="l">
-              <a:lnSpc>
-                <a:spcPct val="120000"/>
-              </a:lnSpc>
-            </a:pPr>
+            <a:pPr algn="l"/>
             <a:r>
-              <a:rPr sz="1050" b="1" i="0">
+              <a:rPr sz="1150" b="1" i="0">
                 <a:solidFill>
                   <a:srgbClr val="101828"/>
                 </a:solidFill>
@@ -26619,14 +26852,14 @@
       </p:sp>
       <p:sp>
         <p:nvSpPr>
-          <p:cNvPr id="537" name="TextBox 536"/>
+          <p:cNvPr id="556" name="TextBox 555"/>
           <p:cNvSpPr txBox="1"/>
           <p:nvPr/>
         </p:nvSpPr>
         <p:spPr>
           <a:xfrm>
-            <a:off x="8897112" y="5468112"/>
-            <a:ext cx="3017520" cy="228600"/>
+            <a:off x="9829800" y="5413248"/>
+            <a:ext cx="2057400" cy="274320"/>
           </a:xfrm>
           <a:prstGeom prst="rect">
             <a:avLst/>
@@ -26634,20 +26867,16 @@
           <a:noFill/>
         </p:spPr>
         <p:txBody>
-          <a:bodyPr wrap="square" lIns="0" rIns="0" tIns="0" bIns="0" anchor="t">
+          <a:bodyPr wrap="none" lIns="0" rIns="0" tIns="0" bIns="0" anchor="ctr">
             <a:spAutoFit/>
           </a:bodyPr>
           <a:lstStyle/>
           <a:p>
-            <a:pPr algn="l">
-              <a:lnSpc>
-                <a:spcPct val="120000"/>
-              </a:lnSpc>
-            </a:pPr>
+            <a:pPr algn="r"/>
             <a:r>
-              <a:rPr sz="950" b="0" i="0">
+              <a:rPr sz="1050" b="0" i="0">
                 <a:solidFill>
-                  <a:srgbClr val="5F6A7A"/>
+                  <a:srgbClr val="00684A"/>
                 </a:solidFill>
                 <a:latin typeface="Menlo"/>
               </a:rPr>
@@ -26658,14 +26887,14 @@
       </p:sp>
       <p:sp>
         <p:nvSpPr>
-          <p:cNvPr id="538" name="Rectangle 537"/>
-          <p:cNvSpPr/>
-          <p:nvPr/>
-        </p:nvSpPr>
-        <p:spPr>
-          <a:xfrm>
-            <a:off x="5349240" y="5806440"/>
-            <a:ext cx="54864" cy="502920"/>
+          <p:cNvPr id="557" name="Rectangle 556"/>
+          <p:cNvSpPr/>
+          <p:nvPr/>
+        </p:nvSpPr>
+        <p:spPr>
+          <a:xfrm>
+            <a:off x="5349240" y="5724144"/>
+            <a:ext cx="54864" cy="274320"/>
           </a:xfrm>
           <a:prstGeom prst="rect">
             <a:avLst/>
@@ -26700,16 +26929,51 @@
           </a:p>
         </p:txBody>
       </p:sp>
-      <p:sp>
-        <p:nvSpPr>
-          <p:cNvPr id="539" name="TextBox 538"/>
+      <p:cxnSp>
+        <p:nvCxnSpPr>
+          <p:cNvPr id="558" name="Connector 557"/>
+          <p:cNvCxnSpPr/>
+          <p:nvPr/>
+        </p:nvCxnSpPr>
+        <p:spPr>
+          <a:xfrm>
+            <a:off x="5349240" y="6016752.0"/>
+            <a:ext cx="6583680" cy="0.0"/>
+          </a:xfrm>
+          <a:prstGeom prst="line">
+            <a:avLst/>
+          </a:prstGeom>
+          <a:ln w="5080">
+            <a:solidFill>
+              <a:srgbClr val="ECE6D6"/>
+            </a:solidFill>
+          </a:ln>
+        </p:spPr>
+        <p:style>
+          <a:lnRef idx="2">
+            <a:schemeClr val="accent1"/>
+          </a:lnRef>
+          <a:fillRef idx="0">
+            <a:schemeClr val="accent1"/>
+          </a:fillRef>
+          <a:effectRef idx="1">
+            <a:schemeClr val="accent1"/>
+          </a:effectRef>
+          <a:fontRef idx="minor">
+            <a:schemeClr val="tx1"/>
+          </a:fontRef>
+        </p:style>
+      </p:cxnSp>
+      <p:sp>
+        <p:nvSpPr>
+          <p:cNvPr id="559" name="TextBox 558"/>
           <p:cNvSpPr txBox="1"/>
           <p:nvPr/>
         </p:nvSpPr>
         <p:spPr>
           <a:xfrm>
-            <a:off x="5513832" y="5843016"/>
-            <a:ext cx="3017520" cy="274320"/>
+            <a:off x="5532120" y="5724144"/>
+            <a:ext cx="4389120" cy="274320"/>
           </a:xfrm>
           <a:prstGeom prst="rect">
             <a:avLst/>
@@ -26717,18 +26981,163 @@
           <a:noFill/>
         </p:spPr>
         <p:txBody>
-          <a:bodyPr wrap="square" lIns="0" rIns="0" tIns="0" bIns="0" anchor="t">
+          <a:bodyPr wrap="none" lIns="0" rIns="0" tIns="0" bIns="0" anchor="ctr">
             <a:spAutoFit/>
           </a:bodyPr>
           <a:lstStyle/>
           <a:p>
-            <a:pPr algn="l">
-              <a:lnSpc>
-                <a:spcPct val="120000"/>
-              </a:lnSpc>
-            </a:pPr>
+            <a:pPr algn="l"/>
             <a:r>
-              <a:rPr sz="1050" b="1" i="0">
+              <a:rPr sz="1150" b="1" i="0">
+                <a:solidFill>
+                  <a:srgbClr val="101828"/>
+                </a:solidFill>
+                <a:latin typeface="Helvetica Neue"/>
+              </a:rPr>
+              <a:t>Ivan Romanov</a:t>
+            </a:r>
+          </a:p>
+        </p:txBody>
+      </p:sp>
+      <p:sp>
+        <p:nvSpPr>
+          <p:cNvPr id="560" name="TextBox 559"/>
+          <p:cNvSpPr txBox="1"/>
+          <p:nvPr/>
+        </p:nvSpPr>
+        <p:spPr>
+          <a:xfrm>
+            <a:off x="9829800" y="5724144"/>
+            <a:ext cx="2057400" cy="274320"/>
+          </a:xfrm>
+          <a:prstGeom prst="rect">
+            <a:avLst/>
+          </a:prstGeom>
+          <a:noFill/>
+        </p:spPr>
+        <p:txBody>
+          <a:bodyPr wrap="none" lIns="0" rIns="0" tIns="0" bIns="0" anchor="ctr">
+            <a:spAutoFit/>
+          </a:bodyPr>
+          <a:lstStyle/>
+          <a:p>
+            <a:pPr algn="r"/>
+            <a:r>
+              <a:rPr sz="1050" b="0" i="0">
+                <a:solidFill>
+                  <a:srgbClr val="00684A"/>
+                </a:solidFill>
+                <a:latin typeface="Menlo"/>
+              </a:rPr>
+              <a:t>20240639</a:t>
+            </a:r>
+          </a:p>
+        </p:txBody>
+      </p:sp>
+      <p:sp>
+        <p:nvSpPr>
+          <p:cNvPr id="561" name="Rectangle 560"/>
+          <p:cNvSpPr/>
+          <p:nvPr/>
+        </p:nvSpPr>
+        <p:spPr>
+          <a:xfrm>
+            <a:off x="5349240" y="6035040"/>
+            <a:ext cx="54864" cy="274320"/>
+          </a:xfrm>
+          <a:prstGeom prst="rect">
+            <a:avLst/>
+          </a:prstGeom>
+          <a:solidFill>
+            <a:srgbClr val="00684A"/>
+          </a:solidFill>
+          <a:ln>
+            <a:noFill/>
+          </a:ln>
+          <a:effectLst/>
+        </p:spPr>
+        <p:style>
+          <a:lnRef idx="1">
+            <a:schemeClr val="accent1"/>
+          </a:lnRef>
+          <a:fillRef idx="3">
+            <a:schemeClr val="accent1"/>
+          </a:fillRef>
+          <a:effectRef idx="2">
+            <a:schemeClr val="accent1"/>
+          </a:effectRef>
+          <a:fontRef idx="minor">
+            <a:schemeClr val="lt1"/>
+          </a:fontRef>
+        </p:style>
+        <p:txBody>
+          <a:bodyPr rtlCol="0" anchor="ctr"/>
+          <a:lstStyle/>
+          <a:p>
+            <a:pPr algn="ctr"/>
+          </a:p>
+        </p:txBody>
+      </p:sp>
+      <p:cxnSp>
+        <p:nvCxnSpPr>
+          <p:cNvPr id="562" name="Connector 561"/>
+          <p:cNvCxnSpPr/>
+          <p:nvPr/>
+        </p:nvCxnSpPr>
+        <p:spPr>
+          <a:xfrm>
+            <a:off x="5349240" y="6327648.0"/>
+            <a:ext cx="6583680" cy="0.0"/>
+          </a:xfrm>
+          <a:prstGeom prst="line">
+            <a:avLst/>
+          </a:prstGeom>
+          <a:ln w="5080">
+            <a:solidFill>
+              <a:srgbClr val="ECE6D6"/>
+            </a:solidFill>
+          </a:ln>
+        </p:spPr>
+        <p:style>
+          <a:lnRef idx="2">
+            <a:schemeClr val="accent1"/>
+          </a:lnRef>
+          <a:fillRef idx="0">
+            <a:schemeClr val="accent1"/>
+          </a:fillRef>
+          <a:effectRef idx="1">
+            <a:schemeClr val="accent1"/>
+          </a:effectRef>
+          <a:fontRef idx="minor">
+            <a:schemeClr val="tx1"/>
+          </a:fontRef>
+        </p:style>
+      </p:cxnSp>
+      <p:sp>
+        <p:nvSpPr>
+          <p:cNvPr id="563" name="TextBox 562"/>
+          <p:cNvSpPr txBox="1"/>
+          <p:nvPr/>
+        </p:nvSpPr>
+        <p:spPr>
+          <a:xfrm>
+            <a:off x="5532120" y="6035040"/>
+            <a:ext cx="4389120" cy="274320"/>
+          </a:xfrm>
+          <a:prstGeom prst="rect">
+            <a:avLst/>
+          </a:prstGeom>
+          <a:noFill/>
+        </p:spPr>
+        <p:txBody>
+          <a:bodyPr wrap="none" lIns="0" rIns="0" tIns="0" bIns="0" anchor="ctr">
+            <a:spAutoFit/>
+          </a:bodyPr>
+          <a:lstStyle/>
+          <a:p>
+            <a:pPr algn="l"/>
+            <a:r>
+              <a:rPr sz="1150" b="1" i="0">
                 <a:solidFill>
                   <a:srgbClr val="101828"/>
                 </a:solidFill>
@@ -26741,14 +27150,14 @@
       </p:sp>
       <p:sp>
         <p:nvSpPr>
-          <p:cNvPr id="540" name="TextBox 539"/>
+          <p:cNvPr id="564" name="TextBox 563"/>
           <p:cNvSpPr txBox="1"/>
           <p:nvPr/>
         </p:nvSpPr>
         <p:spPr>
           <a:xfrm>
-            <a:off x="5513832" y="6062472"/>
-            <a:ext cx="3017520" cy="228600"/>
+            <a:off x="9829800" y="6035040"/>
+            <a:ext cx="2057400" cy="274320"/>
           </a:xfrm>
           <a:prstGeom prst="rect">
             <a:avLst/>
@@ -26756,20 +27165,16 @@
           <a:noFill/>
         </p:spPr>
         <p:txBody>
-          <a:bodyPr wrap="square" lIns="0" rIns="0" tIns="0" bIns="0" anchor="t">
+          <a:bodyPr wrap="none" lIns="0" rIns="0" tIns="0" bIns="0" anchor="ctr">
             <a:spAutoFit/>
           </a:bodyPr>
           <a:lstStyle/>
           <a:p>
-            <a:pPr algn="l">
-              <a:lnSpc>
-                <a:spcPct val="120000"/>
-              </a:lnSpc>
-            </a:pPr>
+            <a:pPr algn="r"/>
             <a:r>
-              <a:rPr sz="950" b="0" i="0">
+              <a:rPr sz="1050" b="0" i="0">
                 <a:solidFill>
-                  <a:srgbClr val="5F6A7A"/>
+                  <a:srgbClr val="00684A"/>
                 </a:solidFill>
                 <a:latin typeface="Menlo"/>
               </a:rPr>
@@ -26780,14 +27185,14 @@
       </p:sp>
       <p:sp>
         <p:nvSpPr>
-          <p:cNvPr id="541" name="Rectangle 540"/>
-          <p:cNvSpPr/>
-          <p:nvPr/>
-        </p:nvSpPr>
-        <p:spPr>
-          <a:xfrm>
-            <a:off x="8732520" y="5806440"/>
-            <a:ext cx="54864" cy="502920"/>
+          <p:cNvPr id="565" name="Rectangle 564"/>
+          <p:cNvSpPr/>
+          <p:nvPr/>
+        </p:nvSpPr>
+        <p:spPr>
+          <a:xfrm>
+            <a:off x="5349240" y="6345936"/>
+            <a:ext cx="54864" cy="274320"/>
           </a:xfrm>
           <a:prstGeom prst="rect">
             <a:avLst/>
@@ -26824,14 +27229,14 @@
       </p:sp>
       <p:sp>
         <p:nvSpPr>
-          <p:cNvPr id="542" name="TextBox 541"/>
+          <p:cNvPr id="566" name="TextBox 565"/>
           <p:cNvSpPr txBox="1"/>
           <p:nvPr/>
         </p:nvSpPr>
         <p:spPr>
           <a:xfrm>
-            <a:off x="8897112" y="5843016"/>
-            <a:ext cx="3017520" cy="274320"/>
+            <a:off x="5532120" y="6345936"/>
+            <a:ext cx="4389120" cy="274320"/>
           </a:xfrm>
           <a:prstGeom prst="rect">
             <a:avLst/>
@@ -26839,18 +27244,14 @@
           <a:noFill/>
         </p:spPr>
         <p:txBody>
-          <a:bodyPr wrap="square" lIns="0" rIns="0" tIns="0" bIns="0" anchor="t">
+          <a:bodyPr wrap="none" lIns="0" rIns="0" tIns="0" bIns="0" anchor="ctr">
             <a:spAutoFit/>
           </a:bodyPr>
           <a:lstStyle/>
           <a:p>
-            <a:pPr algn="l">
-              <a:lnSpc>
-                <a:spcPct val="120000"/>
-              </a:lnSpc>
-            </a:pPr>
+            <a:pPr algn="l"/>
             <a:r>
-              <a:rPr sz="1050" b="1" i="0">
+              <a:rPr sz="1150" b="1" i="0">
                 <a:solidFill>
                   <a:srgbClr val="101828"/>
                 </a:solidFill>
@@ -26863,14 +27264,14 @@
       </p:sp>
       <p:sp>
         <p:nvSpPr>
-          <p:cNvPr id="543" name="TextBox 542"/>
+          <p:cNvPr id="567" name="TextBox 566"/>
           <p:cNvSpPr txBox="1"/>
           <p:nvPr/>
         </p:nvSpPr>
         <p:spPr>
           <a:xfrm>
-            <a:off x="8897112" y="6062472"/>
-            <a:ext cx="3017520" cy="228600"/>
+            <a:off x="9829800" y="6345936"/>
+            <a:ext cx="2057400" cy="274320"/>
           </a:xfrm>
           <a:prstGeom prst="rect">
             <a:avLst/>
@@ -26878,20 +27279,16 @@
           <a:noFill/>
         </p:spPr>
         <p:txBody>
-          <a:bodyPr wrap="square" lIns="0" rIns="0" tIns="0" bIns="0" anchor="t">
+          <a:bodyPr wrap="none" lIns="0" rIns="0" tIns="0" bIns="0" anchor="ctr">
             <a:spAutoFit/>
           </a:bodyPr>
           <a:lstStyle/>
           <a:p>
-            <a:pPr algn="l">
-              <a:lnSpc>
-                <a:spcPct val="120000"/>
-              </a:lnSpc>
-            </a:pPr>
+            <a:pPr algn="r"/>
             <a:r>
-              <a:rPr sz="950" b="0" i="0">
+              <a:rPr sz="1050" b="0" i="0">
                 <a:solidFill>
-                  <a:srgbClr val="5F6A7A"/>
+                  <a:srgbClr val="00684A"/>
                 </a:solidFill>
                 <a:latin typeface="Menlo"/>
               </a:rPr>

</xml_diff>